<commit_message>
Fix footer overlap on slide 5, chart colors on slides 16/17, confounders spacing on slide 19
Slide 5: Regenerated chart11 (49-district ranking) at 8.0x5.8 aspect
ratio so the bar chart no longer extends into the footer zone at y=7.15.
Added analysis/build_chart11.py as standalone builder.

Slides 16+17: Introduced CHART_* bright palette in STYLE.md — same hues
as the deck text palette but at higher lightness for bar/line readability.
Regenerated chart14 (5-series subgroup bars, slide 16) and chart13
(Long Beach time series, slide 17) with the new palette: DC3545 red,
28A745 green, 4A90D9 blue, F0A030 amber, 9B59B6 purple. Added
analysis/build_chart14.py and analysis/build_chart13.py.

Slide 19: Moved confounders box from y=6.95 to y=6.55 (ends at 6.97)
and shortened green panels from h=5.0 to h=4.6 so nothing crosses
the y=7.05 content boundary.

Drift check: 0 HEX_OUTSIDE_PALETTE, 0 CONTENT_BELOW_FOOTER.

Co-Authored-By: Claude Opus 4.7 (1M context) <noreply@anthropic.com>
</commit_message>
<xml_diff>
--- a/deck/Troy_K5_ELA_Executive_Summary.pptx
+++ b/deck/Troy_K5_ELA_Executive_Summary.pptx
@@ -8528,7 +8528,7 @@
         <p:spPr>
           <a:xfrm>
             <a:off x="365760" y="868680"/>
-            <a:ext cx="7772400" cy="4185138"/>
+            <a:ext cx="7772400" cy="2989647"/>
           </a:xfrm>
           <a:prstGeom prst="rect">
             <a:avLst/>
@@ -9350,7 +9350,7 @@
         <p:spPr>
           <a:xfrm>
             <a:off x="365760" y="868680"/>
-            <a:ext cx="7772400" cy="2989647"/>
+            <a:ext cx="7772400" cy="2992272"/>
           </a:xfrm>
           <a:prstGeom prst="rect">
             <a:avLst/>
@@ -10934,7 +10934,7 @@
         <p:spPr>
           <a:xfrm>
             <a:off x="365760" y="1691640"/>
-            <a:ext cx="5669280" cy="4572000"/>
+            <a:ext cx="5669280" cy="4206240"/>
           </a:xfrm>
           <a:prstGeom prst="rect">
             <a:avLst/>
@@ -11013,7 +11013,7 @@
         <p:spPr>
           <a:xfrm>
             <a:off x="502920" y="2194560"/>
-            <a:ext cx="5486400" cy="4023360"/>
+            <a:ext cx="5486400" cy="3657600"/>
           </a:xfrm>
           <a:prstGeom prst="rect">
             <a:avLst/>
@@ -11204,7 +11204,7 @@
         <p:spPr>
           <a:xfrm>
             <a:off x="6172200" y="1691640"/>
-            <a:ext cx="5623560" cy="4572000"/>
+            <a:ext cx="5623560" cy="4206240"/>
           </a:xfrm>
           <a:prstGeom prst="rect">
             <a:avLst/>
@@ -11283,7 +11283,7 @@
         <p:spPr>
           <a:xfrm>
             <a:off x="6309360" y="2194560"/>
-            <a:ext cx="5486400" cy="4023360"/>
+            <a:ext cx="5486400" cy="3657600"/>
           </a:xfrm>
           <a:prstGeom prst="rect">
             <a:avLst/>
@@ -11485,8 +11485,8 @@
         </p:nvSpPr>
         <p:spPr>
           <a:xfrm>
-            <a:off x="365760" y="6355080"/>
-            <a:ext cx="11430000" cy="411480"/>
+            <a:off x="365760" y="5989320"/>
+            <a:ext cx="11430000" cy="384048"/>
           </a:xfrm>
           <a:prstGeom prst="rect">
             <a:avLst/>
@@ -11529,7 +11529,7 @@
         </p:nvSpPr>
         <p:spPr>
           <a:xfrm>
-            <a:off x="502920" y="6400800"/>
+            <a:off x="502920" y="6035040"/>
             <a:ext cx="2560320" cy="274320"/>
           </a:xfrm>
           <a:prstGeom prst="rect">
@@ -11564,7 +11564,7 @@
         </p:nvSpPr>
         <p:spPr>
           <a:xfrm>
-            <a:off x="3108960" y="6400800"/>
+            <a:off x="3108960" y="6035040"/>
             <a:ext cx="8686800" cy="320040"/>
           </a:xfrm>
           <a:prstGeom prst="rect">
@@ -29671,7 +29671,7 @@
         <p:spPr>
           <a:xfrm>
             <a:off x="365760" y="868680"/>
-            <a:ext cx="7498079" cy="7498079"/>
+            <a:ext cx="7498079" cy="5394438"/>
           </a:xfrm>
           <a:prstGeom prst="rect">
             <a:avLst/>

</xml_diff>

<commit_message>
Design validation pass: fix footer overlaps, slide 11 colors, slide 5 legend, slides 16/17 whitespace
- Slide 5: add missing "Not classified" entry to chart legend for gray bars
- Slide 10: increase red box height to prevent text overflow, shift downstream elements
- Slide 11: replace murky olive/brown/red box colors with brand palette (TROY_BLUE/ACCENT_ORANGE/ACCENT_RED)
- Slide 12: constrain chart height to 5.85in (was overflowing at 7.15in), shift right panel left
- Slides 16/17: regenerate charts 13/14 with taller figsize (11.5×7.5) to fill whitespace
- All slides: move footer from y=7.15 to y=7.22, reduce font 8.5→8pt for more content clearance
- index.html: fix slide counter (27→28)

Co-Authored-By: Claude Opus 4.6 <noreply@anthropic.com>
</commit_message>
<xml_diff>
--- a/deck/Troy_K5_ELA_Executive_Summary.pptx
+++ b/deck/Troy_K5_ELA_Executive_Summary.pptx
@@ -3578,7 +3578,7 @@
         <p:spPr>
           <a:xfrm>
             <a:off x="8183879" y="914400"/>
-            <a:ext cx="3749039" cy="2697480"/>
+            <a:ext cx="3749039" cy="2880360"/>
           </a:xfrm>
           <a:prstGeom prst="rect">
             <a:avLst/>
@@ -4295,8 +4295,8 @@
         </p:nvSpPr>
         <p:spPr>
           <a:xfrm>
-            <a:off x="8183879" y="3703320"/>
-            <a:ext cx="3749039" cy="2423160"/>
+            <a:off x="8183879" y="3886200"/>
+            <a:ext cx="3749039" cy="2240280"/>
           </a:xfrm>
           <a:prstGeom prst="rect">
             <a:avLst/>
@@ -4339,7 +4339,7 @@
         </p:nvSpPr>
         <p:spPr>
           <a:xfrm>
-            <a:off x="8321040" y="3767328"/>
+            <a:off x="8321040" y="3950208"/>
             <a:ext cx="3520440" cy="292608"/>
           </a:xfrm>
           <a:prstGeom prst="rect">
@@ -4374,8 +4374,8 @@
         </p:nvSpPr>
         <p:spPr>
           <a:xfrm>
-            <a:off x="8321040" y="4114800"/>
-            <a:ext cx="3520440" cy="1965960"/>
+            <a:off x="8321040" y="4251960"/>
+            <a:ext cx="3520440" cy="1828800"/>
           </a:xfrm>
           <a:prstGeom prst="rect">
             <a:avLst/>
@@ -4596,23 +4596,23 @@
         </p:nvSpPr>
         <p:spPr>
           <a:xfrm>
-            <a:off x="365760" y="6537960"/>
-            <a:ext cx="7315200" cy="274320"/>
-          </a:xfrm>
-          <a:prstGeom prst="rect">
-            <a:avLst/>
-          </a:prstGeom>
-          <a:noFill/>
-        </p:spPr>
-        <p:txBody>
-          <a:bodyPr wrap="square" lIns="0" rIns="0" tIns="0" bIns="0">
-            <a:spAutoFit/>
-          </a:bodyPr>
-          <a:lstStyle/>
-          <a:p>
-            <a:pPr algn="l"/>
-            <a:r>
-              <a:rPr sz="850" b="0" i="0">
+            <a:off x="365760" y="6601968"/>
+            <a:ext cx="7315200" cy="228600"/>
+          </a:xfrm>
+          <a:prstGeom prst="rect">
+            <a:avLst/>
+          </a:prstGeom>
+          <a:noFill/>
+        </p:spPr>
+        <p:txBody>
+          <a:bodyPr wrap="square" lIns="0" rIns="0" tIns="0" bIns="0">
+            <a:spAutoFit/>
+          </a:bodyPr>
+          <a:lstStyle/>
+          <a:p>
+            <a:pPr algn="l"/>
+            <a:r>
+              <a:rPr sz="800" b="0" i="0">
                 <a:solidFill>
                   <a:srgbClr val="707070"/>
                 </a:solidFill>
@@ -4631,8 +4631,8 @@
         </p:nvSpPr>
         <p:spPr>
           <a:xfrm>
-            <a:off x="10515600" y="6537960"/>
-            <a:ext cx="1371600" cy="274320"/>
+            <a:off x="10515600" y="6601968"/>
+            <a:ext cx="1371600" cy="228600"/>
           </a:xfrm>
           <a:prstGeom prst="rect">
             <a:avLst/>
@@ -4647,7 +4647,7 @@
           <a:p>
             <a:pPr algn="r"/>
             <a:r>
-              <a:rPr sz="850" b="0" i="0">
+              <a:rPr sz="800" b="0" i="0">
                 <a:solidFill>
                   <a:srgbClr val="707070"/>
                 </a:solidFill>
@@ -4805,7 +4805,7 @@
             <a:avLst/>
           </a:prstGeom>
           <a:solidFill>
-            <a:srgbClr val="999933"/>
+            <a:srgbClr val="1F3A5F"/>
           </a:solidFill>
           <a:ln>
             <a:noFill/>
@@ -5002,7 +5002,7 @@
             <a:avLst/>
           </a:prstGeom>
           <a:solidFill>
-            <a:srgbClr val="996633"/>
+            <a:srgbClr val="CC6A11"/>
           </a:solidFill>
           <a:ln>
             <a:noFill/>
@@ -5199,7 +5199,7 @@
             <a:avLst/>
           </a:prstGeom>
           <a:solidFill>
-            <a:srgbClr val="993322"/>
+            <a:srgbClr val="B02121"/>
           </a:solidFill>
           <a:ln>
             <a:noFill/>
@@ -5389,23 +5389,23 @@
         </p:nvSpPr>
         <p:spPr>
           <a:xfrm>
-            <a:off x="365760" y="6537960"/>
-            <a:ext cx="7315200" cy="274320"/>
-          </a:xfrm>
-          <a:prstGeom prst="rect">
-            <a:avLst/>
-          </a:prstGeom>
-          <a:noFill/>
-        </p:spPr>
-        <p:txBody>
-          <a:bodyPr wrap="square" lIns="0" rIns="0" tIns="0" bIns="0">
-            <a:spAutoFit/>
-          </a:bodyPr>
-          <a:lstStyle/>
-          <a:p>
-            <a:pPr algn="l"/>
-            <a:r>
-              <a:rPr sz="850" b="0" i="0">
+            <a:off x="365760" y="6601968"/>
+            <a:ext cx="7315200" cy="228600"/>
+          </a:xfrm>
+          <a:prstGeom prst="rect">
+            <a:avLst/>
+          </a:prstGeom>
+          <a:noFill/>
+        </p:spPr>
+        <p:txBody>
+          <a:bodyPr wrap="square" lIns="0" rIns="0" tIns="0" bIns="0">
+            <a:spAutoFit/>
+          </a:bodyPr>
+          <a:lstStyle/>
+          <a:p>
+            <a:pPr algn="l"/>
+            <a:r>
+              <a:rPr sz="800" b="0" i="0">
                 <a:solidFill>
                   <a:srgbClr val="707070"/>
                 </a:solidFill>
@@ -5424,8 +5424,8 @@
         </p:nvSpPr>
         <p:spPr>
           <a:xfrm>
-            <a:off x="10515600" y="6537960"/>
-            <a:ext cx="1371600" cy="274320"/>
+            <a:off x="10515600" y="6601968"/>
+            <a:ext cx="1371600" cy="228600"/>
           </a:xfrm>
           <a:prstGeom prst="rect">
             <a:avLst/>
@@ -5440,7 +5440,7 @@
           <a:p>
             <a:pPr algn="r"/>
             <a:r>
-              <a:rPr sz="850" b="0" i="0">
+              <a:rPr sz="800" b="0" i="0">
                 <a:solidFill>
                   <a:srgbClr val="707070"/>
                 </a:solidFill>
@@ -5600,7 +5600,7 @@
         <p:spPr>
           <a:xfrm>
             <a:off x="365760" y="914400"/>
-            <a:ext cx="7132320" cy="6537960"/>
+            <a:ext cx="5835535" cy="5349240"/>
           </a:xfrm>
           <a:prstGeom prst="rect">
             <a:avLst/>
@@ -5615,8 +5615,8 @@
         </p:nvSpPr>
         <p:spPr>
           <a:xfrm>
-            <a:off x="7680960" y="914400"/>
-            <a:ext cx="4297680" cy="5486400"/>
+            <a:off x="6400800" y="914400"/>
+            <a:ext cx="5486400" cy="5349240"/>
           </a:xfrm>
           <a:prstGeom prst="rect">
             <a:avLst/>
@@ -5659,8 +5659,8 @@
         </p:nvSpPr>
         <p:spPr>
           <a:xfrm>
-            <a:off x="7818120" y="1051560"/>
-            <a:ext cx="4023360" cy="365760"/>
+            <a:off x="6537960" y="1051560"/>
+            <a:ext cx="5212080" cy="365760"/>
           </a:xfrm>
           <a:prstGeom prst="rect">
             <a:avLst/>
@@ -5694,8 +5694,8 @@
         </p:nvSpPr>
         <p:spPr>
           <a:xfrm>
-            <a:off x="7818120" y="1417320"/>
-            <a:ext cx="4023360" cy="1463040"/>
+            <a:off x="6537960" y="1417320"/>
+            <a:ext cx="5212080" cy="1463040"/>
           </a:xfrm>
           <a:prstGeom prst="rect">
             <a:avLst/>
@@ -5777,8 +5777,8 @@
         </p:nvSpPr>
         <p:spPr>
           <a:xfrm>
-            <a:off x="7818120" y="2971800"/>
-            <a:ext cx="4023360" cy="365760"/>
+            <a:off x="6537960" y="2971800"/>
+            <a:ext cx="5212080" cy="365760"/>
           </a:xfrm>
           <a:prstGeom prst="rect">
             <a:avLst/>
@@ -5812,8 +5812,8 @@
         </p:nvSpPr>
         <p:spPr>
           <a:xfrm>
-            <a:off x="7818120" y="3337560"/>
-            <a:ext cx="4023360" cy="1463040"/>
+            <a:off x="6537960" y="3337560"/>
+            <a:ext cx="5212080" cy="1463040"/>
           </a:xfrm>
           <a:prstGeom prst="rect">
             <a:avLst/>
@@ -5895,8 +5895,8 @@
         </p:nvSpPr>
         <p:spPr>
           <a:xfrm>
-            <a:off x="7818120" y="4937760"/>
-            <a:ext cx="4023360" cy="365760"/>
+            <a:off x="6537960" y="4937760"/>
+            <a:ext cx="5212080" cy="365760"/>
           </a:xfrm>
           <a:prstGeom prst="rect">
             <a:avLst/>
@@ -5930,8 +5930,8 @@
         </p:nvSpPr>
         <p:spPr>
           <a:xfrm>
-            <a:off x="7818120" y="5303520"/>
-            <a:ext cx="4023360" cy="1280160"/>
+            <a:off x="6537960" y="5303520"/>
+            <a:ext cx="5212080" cy="914400"/>
           </a:xfrm>
           <a:prstGeom prst="rect">
             <a:avLst/>
@@ -5989,23 +5989,23 @@
         </p:nvSpPr>
         <p:spPr>
           <a:xfrm>
-            <a:off x="365760" y="6537960"/>
-            <a:ext cx="7315200" cy="274320"/>
-          </a:xfrm>
-          <a:prstGeom prst="rect">
-            <a:avLst/>
-          </a:prstGeom>
-          <a:noFill/>
-        </p:spPr>
-        <p:txBody>
-          <a:bodyPr wrap="square" lIns="0" rIns="0" tIns="0" bIns="0">
-            <a:spAutoFit/>
-          </a:bodyPr>
-          <a:lstStyle/>
-          <a:p>
-            <a:pPr algn="l"/>
-            <a:r>
-              <a:rPr sz="850" b="0" i="0">
+            <a:off x="365760" y="6601968"/>
+            <a:ext cx="7315200" cy="228600"/>
+          </a:xfrm>
+          <a:prstGeom prst="rect">
+            <a:avLst/>
+          </a:prstGeom>
+          <a:noFill/>
+        </p:spPr>
+        <p:txBody>
+          <a:bodyPr wrap="square" lIns="0" rIns="0" tIns="0" bIns="0">
+            <a:spAutoFit/>
+          </a:bodyPr>
+          <a:lstStyle/>
+          <a:p>
+            <a:pPr algn="l"/>
+            <a:r>
+              <a:rPr sz="800" b="0" i="0">
                 <a:solidFill>
                   <a:srgbClr val="707070"/>
                 </a:solidFill>
@@ -6024,8 +6024,8 @@
         </p:nvSpPr>
         <p:spPr>
           <a:xfrm>
-            <a:off x="10515600" y="6537960"/>
-            <a:ext cx="1371600" cy="274320"/>
+            <a:off x="10515600" y="6601968"/>
+            <a:ext cx="1371600" cy="228600"/>
           </a:xfrm>
           <a:prstGeom prst="rect">
             <a:avLst/>
@@ -6040,7 +6040,7 @@
           <a:p>
             <a:pPr algn="r"/>
             <a:r>
-              <a:rPr sz="850" b="0" i="0">
+              <a:rPr sz="800" b="0" i="0">
                 <a:solidFill>
                   <a:srgbClr val="707070"/>
                 </a:solidFill>
@@ -6565,23 +6565,23 @@
         </p:nvSpPr>
         <p:spPr>
           <a:xfrm>
-            <a:off x="365760" y="6537960"/>
-            <a:ext cx="7315200" cy="274320"/>
-          </a:xfrm>
-          <a:prstGeom prst="rect">
-            <a:avLst/>
-          </a:prstGeom>
-          <a:noFill/>
-        </p:spPr>
-        <p:txBody>
-          <a:bodyPr wrap="square" lIns="0" rIns="0" tIns="0" bIns="0">
-            <a:spAutoFit/>
-          </a:bodyPr>
-          <a:lstStyle/>
-          <a:p>
-            <a:pPr algn="l"/>
-            <a:r>
-              <a:rPr sz="850" b="0" i="0">
+            <a:off x="365760" y="6601968"/>
+            <a:ext cx="7315200" cy="228600"/>
+          </a:xfrm>
+          <a:prstGeom prst="rect">
+            <a:avLst/>
+          </a:prstGeom>
+          <a:noFill/>
+        </p:spPr>
+        <p:txBody>
+          <a:bodyPr wrap="square" lIns="0" rIns="0" tIns="0" bIns="0">
+            <a:spAutoFit/>
+          </a:bodyPr>
+          <a:lstStyle/>
+          <a:p>
+            <a:pPr algn="l"/>
+            <a:r>
+              <a:rPr sz="800" b="0" i="0">
                 <a:solidFill>
                   <a:srgbClr val="707070"/>
                 </a:solidFill>
@@ -6600,8 +6600,8 @@
         </p:nvSpPr>
         <p:spPr>
           <a:xfrm>
-            <a:off x="10515600" y="6537960"/>
-            <a:ext cx="1371600" cy="274320"/>
+            <a:off x="10515600" y="6601968"/>
+            <a:ext cx="1371600" cy="228600"/>
           </a:xfrm>
           <a:prstGeom prst="rect">
             <a:avLst/>
@@ -6616,7 +6616,7 @@
           <a:p>
             <a:pPr algn="r"/>
             <a:r>
-              <a:rPr sz="850" b="0" i="0">
+              <a:rPr sz="800" b="0" i="0">
                 <a:solidFill>
                   <a:srgbClr val="707070"/>
                 </a:solidFill>
@@ -7187,23 +7187,23 @@
         </p:nvSpPr>
         <p:spPr>
           <a:xfrm>
-            <a:off x="365760" y="6537960"/>
-            <a:ext cx="7315200" cy="274320"/>
-          </a:xfrm>
-          <a:prstGeom prst="rect">
-            <a:avLst/>
-          </a:prstGeom>
-          <a:noFill/>
-        </p:spPr>
-        <p:txBody>
-          <a:bodyPr wrap="square" lIns="0" rIns="0" tIns="0" bIns="0">
-            <a:spAutoFit/>
-          </a:bodyPr>
-          <a:lstStyle/>
-          <a:p>
-            <a:pPr algn="l"/>
-            <a:r>
-              <a:rPr sz="850" b="0" i="0">
+            <a:off x="365760" y="6601968"/>
+            <a:ext cx="7315200" cy="228600"/>
+          </a:xfrm>
+          <a:prstGeom prst="rect">
+            <a:avLst/>
+          </a:prstGeom>
+          <a:noFill/>
+        </p:spPr>
+        <p:txBody>
+          <a:bodyPr wrap="square" lIns="0" rIns="0" tIns="0" bIns="0">
+            <a:spAutoFit/>
+          </a:bodyPr>
+          <a:lstStyle/>
+          <a:p>
+            <a:pPr algn="l"/>
+            <a:r>
+              <a:rPr sz="800" b="0" i="0">
                 <a:solidFill>
                   <a:srgbClr val="707070"/>
                 </a:solidFill>
@@ -7222,8 +7222,8 @@
         </p:nvSpPr>
         <p:spPr>
           <a:xfrm>
-            <a:off x="10515600" y="6537960"/>
-            <a:ext cx="1371600" cy="274320"/>
+            <a:off x="10515600" y="6601968"/>
+            <a:ext cx="1371600" cy="228600"/>
           </a:xfrm>
           <a:prstGeom prst="rect">
             <a:avLst/>
@@ -7238,7 +7238,7 @@
           <a:p>
             <a:pPr algn="r"/>
             <a:r>
-              <a:rPr sz="850" b="0" i="0">
+              <a:rPr sz="800" b="0" i="0">
                 <a:solidFill>
                   <a:srgbClr val="707070"/>
                 </a:solidFill>
@@ -8317,23 +8317,23 @@
         </p:nvSpPr>
         <p:spPr>
           <a:xfrm>
-            <a:off x="365760" y="6537960"/>
-            <a:ext cx="7315200" cy="274320"/>
-          </a:xfrm>
-          <a:prstGeom prst="rect">
-            <a:avLst/>
-          </a:prstGeom>
-          <a:noFill/>
-        </p:spPr>
-        <p:txBody>
-          <a:bodyPr wrap="square" lIns="0" rIns="0" tIns="0" bIns="0">
-            <a:spAutoFit/>
-          </a:bodyPr>
-          <a:lstStyle/>
-          <a:p>
-            <a:pPr algn="l"/>
-            <a:r>
-              <a:rPr sz="850" b="0" i="0">
+            <a:off x="365760" y="6601968"/>
+            <a:ext cx="7315200" cy="228600"/>
+          </a:xfrm>
+          <a:prstGeom prst="rect">
+            <a:avLst/>
+          </a:prstGeom>
+          <a:noFill/>
+        </p:spPr>
+        <p:txBody>
+          <a:bodyPr wrap="square" lIns="0" rIns="0" tIns="0" bIns="0">
+            <a:spAutoFit/>
+          </a:bodyPr>
+          <a:lstStyle/>
+          <a:p>
+            <a:pPr algn="l"/>
+            <a:r>
+              <a:rPr sz="800" b="0" i="0">
                 <a:solidFill>
                   <a:srgbClr val="707070"/>
                 </a:solidFill>
@@ -8352,8 +8352,8 @@
         </p:nvSpPr>
         <p:spPr>
           <a:xfrm>
-            <a:off x="10515600" y="6537960"/>
-            <a:ext cx="1371600" cy="274320"/>
+            <a:off x="10515600" y="6601968"/>
+            <a:ext cx="1371600" cy="228600"/>
           </a:xfrm>
           <a:prstGeom prst="rect">
             <a:avLst/>
@@ -8368,7 +8368,7 @@
           <a:p>
             <a:pPr algn="r"/>
             <a:r>
-              <a:rPr sz="850" b="0" i="0">
+              <a:rPr sz="800" b="0" i="0">
                 <a:solidFill>
                   <a:srgbClr val="707070"/>
                 </a:solidFill>
@@ -8528,7 +8528,7 @@
         <p:spPr>
           <a:xfrm>
             <a:off x="365760" y="868680"/>
-            <a:ext cx="7772400" cy="2989647"/>
+            <a:ext cx="7772400" cy="5035015"/>
           </a:xfrm>
           <a:prstGeom prst="rect">
             <a:avLst/>
@@ -9139,23 +9139,23 @@
         </p:nvSpPr>
         <p:spPr>
           <a:xfrm>
-            <a:off x="365760" y="6537960"/>
-            <a:ext cx="7315200" cy="274320"/>
-          </a:xfrm>
-          <a:prstGeom prst="rect">
-            <a:avLst/>
-          </a:prstGeom>
-          <a:noFill/>
-        </p:spPr>
-        <p:txBody>
-          <a:bodyPr wrap="square" lIns="0" rIns="0" tIns="0" bIns="0">
-            <a:spAutoFit/>
-          </a:bodyPr>
-          <a:lstStyle/>
-          <a:p>
-            <a:pPr algn="l"/>
-            <a:r>
-              <a:rPr sz="850" b="0" i="0">
+            <a:off x="365760" y="6601968"/>
+            <a:ext cx="7315200" cy="228600"/>
+          </a:xfrm>
+          <a:prstGeom prst="rect">
+            <a:avLst/>
+          </a:prstGeom>
+          <a:noFill/>
+        </p:spPr>
+        <p:txBody>
+          <a:bodyPr wrap="square" lIns="0" rIns="0" tIns="0" bIns="0">
+            <a:spAutoFit/>
+          </a:bodyPr>
+          <a:lstStyle/>
+          <a:p>
+            <a:pPr algn="l"/>
+            <a:r>
+              <a:rPr sz="800" b="0" i="0">
                 <a:solidFill>
                   <a:srgbClr val="707070"/>
                 </a:solidFill>
@@ -9174,8 +9174,8 @@
         </p:nvSpPr>
         <p:spPr>
           <a:xfrm>
-            <a:off x="10515600" y="6537960"/>
-            <a:ext cx="1371600" cy="274320"/>
+            <a:off x="10515600" y="6601968"/>
+            <a:ext cx="1371600" cy="228600"/>
           </a:xfrm>
           <a:prstGeom prst="rect">
             <a:avLst/>
@@ -9190,7 +9190,7 @@
           <a:p>
             <a:pPr algn="r"/>
             <a:r>
-              <a:rPr sz="850" b="0" i="0">
+              <a:rPr sz="800" b="0" i="0">
                 <a:solidFill>
                   <a:srgbClr val="707070"/>
                 </a:solidFill>
@@ -9350,7 +9350,7 @@
         <p:spPr>
           <a:xfrm>
             <a:off x="365760" y="868680"/>
-            <a:ext cx="7772400" cy="2992272"/>
+            <a:ext cx="7772400" cy="5039436"/>
           </a:xfrm>
           <a:prstGeom prst="rect">
             <a:avLst/>
@@ -9713,23 +9713,23 @@
         </p:nvSpPr>
         <p:spPr>
           <a:xfrm>
-            <a:off x="365760" y="6537960"/>
-            <a:ext cx="7315200" cy="274320"/>
-          </a:xfrm>
-          <a:prstGeom prst="rect">
-            <a:avLst/>
-          </a:prstGeom>
-          <a:noFill/>
-        </p:spPr>
-        <p:txBody>
-          <a:bodyPr wrap="square" lIns="0" rIns="0" tIns="0" bIns="0">
-            <a:spAutoFit/>
-          </a:bodyPr>
-          <a:lstStyle/>
-          <a:p>
-            <a:pPr algn="l"/>
-            <a:r>
-              <a:rPr sz="850" b="0" i="0">
+            <a:off x="365760" y="6601968"/>
+            <a:ext cx="7315200" cy="228600"/>
+          </a:xfrm>
+          <a:prstGeom prst="rect">
+            <a:avLst/>
+          </a:prstGeom>
+          <a:noFill/>
+        </p:spPr>
+        <p:txBody>
+          <a:bodyPr wrap="square" lIns="0" rIns="0" tIns="0" bIns="0">
+            <a:spAutoFit/>
+          </a:bodyPr>
+          <a:lstStyle/>
+          <a:p>
+            <a:pPr algn="l"/>
+            <a:r>
+              <a:rPr sz="800" b="0" i="0">
                 <a:solidFill>
                   <a:srgbClr val="707070"/>
                 </a:solidFill>
@@ -9748,8 +9748,8 @@
         </p:nvSpPr>
         <p:spPr>
           <a:xfrm>
-            <a:off x="10515600" y="6537960"/>
-            <a:ext cx="1371600" cy="274320"/>
+            <a:off x="10515600" y="6601968"/>
+            <a:ext cx="1371600" cy="228600"/>
           </a:xfrm>
           <a:prstGeom prst="rect">
             <a:avLst/>
@@ -9764,7 +9764,7 @@
           <a:p>
             <a:pPr algn="r"/>
             <a:r>
-              <a:rPr sz="850" b="0" i="0">
+              <a:rPr sz="800" b="0" i="0">
                 <a:solidFill>
                   <a:srgbClr val="707070"/>
                 </a:solidFill>
@@ -10617,23 +10617,23 @@
         </p:nvSpPr>
         <p:spPr>
           <a:xfrm>
-            <a:off x="365760" y="6537960"/>
-            <a:ext cx="7315200" cy="274320"/>
-          </a:xfrm>
-          <a:prstGeom prst="rect">
-            <a:avLst/>
-          </a:prstGeom>
-          <a:noFill/>
-        </p:spPr>
-        <p:txBody>
-          <a:bodyPr wrap="square" lIns="0" rIns="0" tIns="0" bIns="0">
-            <a:spAutoFit/>
-          </a:bodyPr>
-          <a:lstStyle/>
-          <a:p>
-            <a:pPr algn="l"/>
-            <a:r>
-              <a:rPr sz="850" b="0" i="0">
+            <a:off x="365760" y="6601968"/>
+            <a:ext cx="7315200" cy="228600"/>
+          </a:xfrm>
+          <a:prstGeom prst="rect">
+            <a:avLst/>
+          </a:prstGeom>
+          <a:noFill/>
+        </p:spPr>
+        <p:txBody>
+          <a:bodyPr wrap="square" lIns="0" rIns="0" tIns="0" bIns="0">
+            <a:spAutoFit/>
+          </a:bodyPr>
+          <a:lstStyle/>
+          <a:p>
+            <a:pPr algn="l"/>
+            <a:r>
+              <a:rPr sz="800" b="0" i="0">
                 <a:solidFill>
                   <a:srgbClr val="707070"/>
                 </a:solidFill>
@@ -10652,8 +10652,8 @@
         </p:nvSpPr>
         <p:spPr>
           <a:xfrm>
-            <a:off x="10515600" y="6537960"/>
-            <a:ext cx="1371600" cy="274320"/>
+            <a:off x="10515600" y="6601968"/>
+            <a:ext cx="1371600" cy="228600"/>
           </a:xfrm>
           <a:prstGeom prst="rect">
             <a:avLst/>
@@ -10668,7 +10668,7 @@
           <a:p>
             <a:pPr algn="r"/>
             <a:r>
-              <a:rPr sz="850" b="0" i="0">
+              <a:rPr sz="800" b="0" i="0">
                 <a:solidFill>
                   <a:srgbClr val="707070"/>
                 </a:solidFill>
@@ -11599,23 +11599,23 @@
         </p:nvSpPr>
         <p:spPr>
           <a:xfrm>
-            <a:off x="365760" y="6537960"/>
-            <a:ext cx="7315200" cy="274320"/>
-          </a:xfrm>
-          <a:prstGeom prst="rect">
-            <a:avLst/>
-          </a:prstGeom>
-          <a:noFill/>
-        </p:spPr>
-        <p:txBody>
-          <a:bodyPr wrap="square" lIns="0" rIns="0" tIns="0" bIns="0">
-            <a:spAutoFit/>
-          </a:bodyPr>
-          <a:lstStyle/>
-          <a:p>
-            <a:pPr algn="l"/>
-            <a:r>
-              <a:rPr sz="850" b="0" i="0">
+            <a:off x="365760" y="6601968"/>
+            <a:ext cx="7315200" cy="228600"/>
+          </a:xfrm>
+          <a:prstGeom prst="rect">
+            <a:avLst/>
+          </a:prstGeom>
+          <a:noFill/>
+        </p:spPr>
+        <p:txBody>
+          <a:bodyPr wrap="square" lIns="0" rIns="0" tIns="0" bIns="0">
+            <a:spAutoFit/>
+          </a:bodyPr>
+          <a:lstStyle/>
+          <a:p>
+            <a:pPr algn="l"/>
+            <a:r>
+              <a:rPr sz="800" b="0" i="0">
                 <a:solidFill>
                   <a:srgbClr val="707070"/>
                 </a:solidFill>
@@ -11634,8 +11634,8 @@
         </p:nvSpPr>
         <p:spPr>
           <a:xfrm>
-            <a:off x="10515600" y="6537960"/>
-            <a:ext cx="1371600" cy="274320"/>
+            <a:off x="10515600" y="6601968"/>
+            <a:ext cx="1371600" cy="228600"/>
           </a:xfrm>
           <a:prstGeom prst="rect">
             <a:avLst/>
@@ -11650,7 +11650,7 @@
           <a:p>
             <a:pPr algn="r"/>
             <a:r>
-              <a:rPr sz="850" b="0" i="0">
+              <a:rPr sz="800" b="0" i="0">
                 <a:solidFill>
                   <a:srgbClr val="707070"/>
                 </a:solidFill>
@@ -12735,23 +12735,23 @@
         </p:nvSpPr>
         <p:spPr>
           <a:xfrm>
-            <a:off x="365760" y="6537960"/>
-            <a:ext cx="7315200" cy="274320"/>
-          </a:xfrm>
-          <a:prstGeom prst="rect">
-            <a:avLst/>
-          </a:prstGeom>
-          <a:noFill/>
-        </p:spPr>
-        <p:txBody>
-          <a:bodyPr wrap="square" lIns="0" rIns="0" tIns="0" bIns="0">
-            <a:spAutoFit/>
-          </a:bodyPr>
-          <a:lstStyle/>
-          <a:p>
-            <a:pPr algn="l"/>
-            <a:r>
-              <a:rPr sz="850" b="0" i="0">
+            <a:off x="365760" y="6601968"/>
+            <a:ext cx="7315200" cy="228600"/>
+          </a:xfrm>
+          <a:prstGeom prst="rect">
+            <a:avLst/>
+          </a:prstGeom>
+          <a:noFill/>
+        </p:spPr>
+        <p:txBody>
+          <a:bodyPr wrap="square" lIns="0" rIns="0" tIns="0" bIns="0">
+            <a:spAutoFit/>
+          </a:bodyPr>
+          <a:lstStyle/>
+          <a:p>
+            <a:pPr algn="l"/>
+            <a:r>
+              <a:rPr sz="800" b="0" i="0">
                 <a:solidFill>
                   <a:srgbClr val="707070"/>
                 </a:solidFill>
@@ -12770,8 +12770,8 @@
         </p:nvSpPr>
         <p:spPr>
           <a:xfrm>
-            <a:off x="10515600" y="6537960"/>
-            <a:ext cx="1371600" cy="274320"/>
+            <a:off x="10515600" y="6601968"/>
+            <a:ext cx="1371600" cy="228600"/>
           </a:xfrm>
           <a:prstGeom prst="rect">
             <a:avLst/>
@@ -12786,7 +12786,7 @@
           <a:p>
             <a:pPr algn="r"/>
             <a:r>
-              <a:rPr sz="850" b="0" i="0">
+              <a:rPr sz="800" b="0" i="0">
                 <a:solidFill>
                   <a:srgbClr val="707070"/>
                 </a:solidFill>
@@ -15317,23 +15317,23 @@
         </p:nvSpPr>
         <p:spPr>
           <a:xfrm>
-            <a:off x="365760" y="6537960"/>
-            <a:ext cx="7315200" cy="274320"/>
-          </a:xfrm>
-          <a:prstGeom prst="rect">
-            <a:avLst/>
-          </a:prstGeom>
-          <a:noFill/>
-        </p:spPr>
-        <p:txBody>
-          <a:bodyPr wrap="square" lIns="0" rIns="0" tIns="0" bIns="0">
-            <a:spAutoFit/>
-          </a:bodyPr>
-          <a:lstStyle/>
-          <a:p>
-            <a:pPr algn="l"/>
-            <a:r>
-              <a:rPr sz="850" b="0" i="0">
+            <a:off x="365760" y="6601968"/>
+            <a:ext cx="7315200" cy="228600"/>
+          </a:xfrm>
+          <a:prstGeom prst="rect">
+            <a:avLst/>
+          </a:prstGeom>
+          <a:noFill/>
+        </p:spPr>
+        <p:txBody>
+          <a:bodyPr wrap="square" lIns="0" rIns="0" tIns="0" bIns="0">
+            <a:spAutoFit/>
+          </a:bodyPr>
+          <a:lstStyle/>
+          <a:p>
+            <a:pPr algn="l"/>
+            <a:r>
+              <a:rPr sz="800" b="0" i="0">
                 <a:solidFill>
                   <a:srgbClr val="707070"/>
                 </a:solidFill>
@@ -15352,8 +15352,8 @@
         </p:nvSpPr>
         <p:spPr>
           <a:xfrm>
-            <a:off x="10515600" y="6537960"/>
-            <a:ext cx="1371600" cy="274320"/>
+            <a:off x="10515600" y="6601968"/>
+            <a:ext cx="1371600" cy="228600"/>
           </a:xfrm>
           <a:prstGeom prst="rect">
             <a:avLst/>
@@ -15368,7 +15368,7 @@
           <a:p>
             <a:pPr algn="r"/>
             <a:r>
-              <a:rPr sz="850" b="0" i="0">
+              <a:rPr sz="800" b="0" i="0">
                 <a:solidFill>
                   <a:srgbClr val="707070"/>
                 </a:solidFill>
@@ -16163,23 +16163,23 @@
         </p:nvSpPr>
         <p:spPr>
           <a:xfrm>
-            <a:off x="365760" y="6537960"/>
-            <a:ext cx="7315200" cy="274320"/>
-          </a:xfrm>
-          <a:prstGeom prst="rect">
-            <a:avLst/>
-          </a:prstGeom>
-          <a:noFill/>
-        </p:spPr>
-        <p:txBody>
-          <a:bodyPr wrap="square" lIns="0" rIns="0" tIns="0" bIns="0">
-            <a:spAutoFit/>
-          </a:bodyPr>
-          <a:lstStyle/>
-          <a:p>
-            <a:pPr algn="l"/>
-            <a:r>
-              <a:rPr sz="850" b="0" i="0">
+            <a:off x="365760" y="6601968"/>
+            <a:ext cx="7315200" cy="228600"/>
+          </a:xfrm>
+          <a:prstGeom prst="rect">
+            <a:avLst/>
+          </a:prstGeom>
+          <a:noFill/>
+        </p:spPr>
+        <p:txBody>
+          <a:bodyPr wrap="square" lIns="0" rIns="0" tIns="0" bIns="0">
+            <a:spAutoFit/>
+          </a:bodyPr>
+          <a:lstStyle/>
+          <a:p>
+            <a:pPr algn="l"/>
+            <a:r>
+              <a:rPr sz="800" b="0" i="0">
                 <a:solidFill>
                   <a:srgbClr val="707070"/>
                 </a:solidFill>
@@ -16198,8 +16198,8 @@
         </p:nvSpPr>
         <p:spPr>
           <a:xfrm>
-            <a:off x="10515600" y="6537960"/>
-            <a:ext cx="1371600" cy="274320"/>
+            <a:off x="10515600" y="6601968"/>
+            <a:ext cx="1371600" cy="228600"/>
           </a:xfrm>
           <a:prstGeom prst="rect">
             <a:avLst/>
@@ -16214,7 +16214,7 @@
           <a:p>
             <a:pPr algn="r"/>
             <a:r>
-              <a:rPr sz="850" b="0" i="0">
+              <a:rPr sz="800" b="0" i="0">
                 <a:solidFill>
                   <a:srgbClr val="707070"/>
                 </a:solidFill>
@@ -18074,23 +18074,23 @@
         </p:nvSpPr>
         <p:spPr>
           <a:xfrm>
-            <a:off x="365760" y="6537960"/>
-            <a:ext cx="7315200" cy="274320"/>
-          </a:xfrm>
-          <a:prstGeom prst="rect">
-            <a:avLst/>
-          </a:prstGeom>
-          <a:noFill/>
-        </p:spPr>
-        <p:txBody>
-          <a:bodyPr wrap="square" lIns="0" rIns="0" tIns="0" bIns="0">
-            <a:spAutoFit/>
-          </a:bodyPr>
-          <a:lstStyle/>
-          <a:p>
-            <a:pPr algn="l"/>
-            <a:r>
-              <a:rPr sz="850" b="0" i="0">
+            <a:off x="365760" y="6601968"/>
+            <a:ext cx="7315200" cy="228600"/>
+          </a:xfrm>
+          <a:prstGeom prst="rect">
+            <a:avLst/>
+          </a:prstGeom>
+          <a:noFill/>
+        </p:spPr>
+        <p:txBody>
+          <a:bodyPr wrap="square" lIns="0" rIns="0" tIns="0" bIns="0">
+            <a:spAutoFit/>
+          </a:bodyPr>
+          <a:lstStyle/>
+          <a:p>
+            <a:pPr algn="l"/>
+            <a:r>
+              <a:rPr sz="800" b="0" i="0">
                 <a:solidFill>
                   <a:srgbClr val="707070"/>
                 </a:solidFill>
@@ -18109,8 +18109,8 @@
         </p:nvSpPr>
         <p:spPr>
           <a:xfrm>
-            <a:off x="10515600" y="6537960"/>
-            <a:ext cx="1371600" cy="274320"/>
+            <a:off x="10515600" y="6601968"/>
+            <a:ext cx="1371600" cy="228600"/>
           </a:xfrm>
           <a:prstGeom prst="rect">
             <a:avLst/>
@@ -18125,7 +18125,7 @@
           <a:p>
             <a:pPr algn="r"/>
             <a:r>
-              <a:rPr sz="850" b="0" i="0">
+              <a:rPr sz="800" b="0" i="0">
                 <a:solidFill>
                   <a:srgbClr val="707070"/>
                 </a:solidFill>
@@ -18842,23 +18842,23 @@
         </p:nvSpPr>
         <p:spPr>
           <a:xfrm>
-            <a:off x="365760" y="6537960"/>
-            <a:ext cx="7315200" cy="274320"/>
-          </a:xfrm>
-          <a:prstGeom prst="rect">
-            <a:avLst/>
-          </a:prstGeom>
-          <a:noFill/>
-        </p:spPr>
-        <p:txBody>
-          <a:bodyPr wrap="square" lIns="0" rIns="0" tIns="0" bIns="0">
-            <a:spAutoFit/>
-          </a:bodyPr>
-          <a:lstStyle/>
-          <a:p>
-            <a:pPr algn="l"/>
-            <a:r>
-              <a:rPr sz="850" b="0" i="0">
+            <a:off x="365760" y="6601968"/>
+            <a:ext cx="7315200" cy="228600"/>
+          </a:xfrm>
+          <a:prstGeom prst="rect">
+            <a:avLst/>
+          </a:prstGeom>
+          <a:noFill/>
+        </p:spPr>
+        <p:txBody>
+          <a:bodyPr wrap="square" lIns="0" rIns="0" tIns="0" bIns="0">
+            <a:spAutoFit/>
+          </a:bodyPr>
+          <a:lstStyle/>
+          <a:p>
+            <a:pPr algn="l"/>
+            <a:r>
+              <a:rPr sz="800" b="0" i="0">
                 <a:solidFill>
                   <a:srgbClr val="707070"/>
                 </a:solidFill>
@@ -18877,8 +18877,8 @@
         </p:nvSpPr>
         <p:spPr>
           <a:xfrm>
-            <a:off x="10515600" y="6537960"/>
-            <a:ext cx="1371600" cy="274320"/>
+            <a:off x="10515600" y="6601968"/>
+            <a:ext cx="1371600" cy="228600"/>
           </a:xfrm>
           <a:prstGeom prst="rect">
             <a:avLst/>
@@ -18893,7 +18893,7 @@
           <a:p>
             <a:pPr algn="r"/>
             <a:r>
-              <a:rPr sz="850" b="0" i="0">
+              <a:rPr sz="800" b="0" i="0">
                 <a:solidFill>
                   <a:srgbClr val="707070"/>
                 </a:solidFill>
@@ -20981,23 +20981,23 @@
         </p:nvSpPr>
         <p:spPr>
           <a:xfrm>
-            <a:off x="365760" y="6537960"/>
-            <a:ext cx="7315200" cy="274320"/>
-          </a:xfrm>
-          <a:prstGeom prst="rect">
-            <a:avLst/>
-          </a:prstGeom>
-          <a:noFill/>
-        </p:spPr>
-        <p:txBody>
-          <a:bodyPr wrap="square" lIns="0" rIns="0" tIns="0" bIns="0">
-            <a:spAutoFit/>
-          </a:bodyPr>
-          <a:lstStyle/>
-          <a:p>
-            <a:pPr algn="l"/>
-            <a:r>
-              <a:rPr sz="850" b="0" i="0">
+            <a:off x="365760" y="6601968"/>
+            <a:ext cx="7315200" cy="228600"/>
+          </a:xfrm>
+          <a:prstGeom prst="rect">
+            <a:avLst/>
+          </a:prstGeom>
+          <a:noFill/>
+        </p:spPr>
+        <p:txBody>
+          <a:bodyPr wrap="square" lIns="0" rIns="0" tIns="0" bIns="0">
+            <a:spAutoFit/>
+          </a:bodyPr>
+          <a:lstStyle/>
+          <a:p>
+            <a:pPr algn="l"/>
+            <a:r>
+              <a:rPr sz="800" b="0" i="0">
                 <a:solidFill>
                   <a:srgbClr val="707070"/>
                 </a:solidFill>
@@ -21016,8 +21016,8 @@
         </p:nvSpPr>
         <p:spPr>
           <a:xfrm>
-            <a:off x="10515600" y="6537960"/>
-            <a:ext cx="1371600" cy="274320"/>
+            <a:off x="10515600" y="6601968"/>
+            <a:ext cx="1371600" cy="228600"/>
           </a:xfrm>
           <a:prstGeom prst="rect">
             <a:avLst/>
@@ -21032,7 +21032,7 @@
           <a:p>
             <a:pPr algn="r"/>
             <a:r>
-              <a:rPr sz="850" b="0" i="0">
+              <a:rPr sz="800" b="0" i="0">
                 <a:solidFill>
                   <a:srgbClr val="707070"/>
                 </a:solidFill>
@@ -22077,23 +22077,23 @@
         </p:nvSpPr>
         <p:spPr>
           <a:xfrm>
-            <a:off x="365760" y="6537960"/>
-            <a:ext cx="7315200" cy="274320"/>
-          </a:xfrm>
-          <a:prstGeom prst="rect">
-            <a:avLst/>
-          </a:prstGeom>
-          <a:noFill/>
-        </p:spPr>
-        <p:txBody>
-          <a:bodyPr wrap="square" lIns="0" rIns="0" tIns="0" bIns="0">
-            <a:spAutoFit/>
-          </a:bodyPr>
-          <a:lstStyle/>
-          <a:p>
-            <a:pPr algn="l"/>
-            <a:r>
-              <a:rPr sz="850" b="0" i="0">
+            <a:off x="365760" y="6601968"/>
+            <a:ext cx="7315200" cy="228600"/>
+          </a:xfrm>
+          <a:prstGeom prst="rect">
+            <a:avLst/>
+          </a:prstGeom>
+          <a:noFill/>
+        </p:spPr>
+        <p:txBody>
+          <a:bodyPr wrap="square" lIns="0" rIns="0" tIns="0" bIns="0">
+            <a:spAutoFit/>
+          </a:bodyPr>
+          <a:lstStyle/>
+          <a:p>
+            <a:pPr algn="l"/>
+            <a:r>
+              <a:rPr sz="800" b="0" i="0">
                 <a:solidFill>
                   <a:srgbClr val="707070"/>
                 </a:solidFill>
@@ -22112,8 +22112,8 @@
         </p:nvSpPr>
         <p:spPr>
           <a:xfrm>
-            <a:off x="10515600" y="6537960"/>
-            <a:ext cx="1371600" cy="274320"/>
+            <a:off x="10515600" y="6601968"/>
+            <a:ext cx="1371600" cy="228600"/>
           </a:xfrm>
           <a:prstGeom prst="rect">
             <a:avLst/>
@@ -22128,7 +22128,7 @@
           <a:p>
             <a:pPr algn="r"/>
             <a:r>
-              <a:rPr sz="850" b="0" i="0">
+              <a:rPr sz="800" b="0" i="0">
                 <a:solidFill>
                   <a:srgbClr val="707070"/>
                 </a:solidFill>
@@ -23769,23 +23769,23 @@
         </p:nvSpPr>
         <p:spPr>
           <a:xfrm>
-            <a:off x="365760" y="6537960"/>
-            <a:ext cx="7315200" cy="274320"/>
-          </a:xfrm>
-          <a:prstGeom prst="rect">
-            <a:avLst/>
-          </a:prstGeom>
-          <a:noFill/>
-        </p:spPr>
-        <p:txBody>
-          <a:bodyPr wrap="square" lIns="0" rIns="0" tIns="0" bIns="0">
-            <a:spAutoFit/>
-          </a:bodyPr>
-          <a:lstStyle/>
-          <a:p>
-            <a:pPr algn="l"/>
-            <a:r>
-              <a:rPr sz="850" b="0" i="0">
+            <a:off x="365760" y="6601968"/>
+            <a:ext cx="7315200" cy="228600"/>
+          </a:xfrm>
+          <a:prstGeom prst="rect">
+            <a:avLst/>
+          </a:prstGeom>
+          <a:noFill/>
+        </p:spPr>
+        <p:txBody>
+          <a:bodyPr wrap="square" lIns="0" rIns="0" tIns="0" bIns="0">
+            <a:spAutoFit/>
+          </a:bodyPr>
+          <a:lstStyle/>
+          <a:p>
+            <a:pPr algn="l"/>
+            <a:r>
+              <a:rPr sz="800" b="0" i="0">
                 <a:solidFill>
                   <a:srgbClr val="707070"/>
                 </a:solidFill>
@@ -23804,8 +23804,8 @@
         </p:nvSpPr>
         <p:spPr>
           <a:xfrm>
-            <a:off x="10515600" y="6537960"/>
-            <a:ext cx="1371600" cy="274320"/>
+            <a:off x="10515600" y="6601968"/>
+            <a:ext cx="1371600" cy="228600"/>
           </a:xfrm>
           <a:prstGeom prst="rect">
             <a:avLst/>
@@ -23820,7 +23820,7 @@
           <a:p>
             <a:pPr algn="r"/>
             <a:r>
-              <a:rPr sz="850" b="0" i="0">
+              <a:rPr sz="800" b="0" i="0">
                 <a:solidFill>
                   <a:srgbClr val="707070"/>
                 </a:solidFill>
@@ -26057,23 +26057,23 @@
         </p:nvSpPr>
         <p:spPr>
           <a:xfrm>
-            <a:off x="365760" y="6537960"/>
-            <a:ext cx="7315200" cy="274320"/>
-          </a:xfrm>
-          <a:prstGeom prst="rect">
-            <a:avLst/>
-          </a:prstGeom>
-          <a:noFill/>
-        </p:spPr>
-        <p:txBody>
-          <a:bodyPr wrap="square" lIns="0" rIns="0" tIns="0" bIns="0">
-            <a:spAutoFit/>
-          </a:bodyPr>
-          <a:lstStyle/>
-          <a:p>
-            <a:pPr algn="l"/>
-            <a:r>
-              <a:rPr sz="850" b="0" i="0">
+            <a:off x="365760" y="6601968"/>
+            <a:ext cx="7315200" cy="228600"/>
+          </a:xfrm>
+          <a:prstGeom prst="rect">
+            <a:avLst/>
+          </a:prstGeom>
+          <a:noFill/>
+        </p:spPr>
+        <p:txBody>
+          <a:bodyPr wrap="square" lIns="0" rIns="0" tIns="0" bIns="0">
+            <a:spAutoFit/>
+          </a:bodyPr>
+          <a:lstStyle/>
+          <a:p>
+            <a:pPr algn="l"/>
+            <a:r>
+              <a:rPr sz="800" b="0" i="0">
                 <a:solidFill>
                   <a:srgbClr val="707070"/>
                 </a:solidFill>
@@ -26092,8 +26092,8 @@
         </p:nvSpPr>
         <p:spPr>
           <a:xfrm>
-            <a:off x="10515600" y="6537960"/>
-            <a:ext cx="1371600" cy="274320"/>
+            <a:off x="10515600" y="6601968"/>
+            <a:ext cx="1371600" cy="228600"/>
           </a:xfrm>
           <a:prstGeom prst="rect">
             <a:avLst/>
@@ -26108,7 +26108,7 @@
           <a:p>
             <a:pPr algn="r"/>
             <a:r>
-              <a:rPr sz="850" b="0" i="0">
+              <a:rPr sz="800" b="0" i="0">
                 <a:solidFill>
                   <a:srgbClr val="707070"/>
                 </a:solidFill>
@@ -27992,23 +27992,23 @@
         </p:nvSpPr>
         <p:spPr>
           <a:xfrm>
-            <a:off x="365760" y="6537960"/>
-            <a:ext cx="7315200" cy="274320"/>
-          </a:xfrm>
-          <a:prstGeom prst="rect">
-            <a:avLst/>
-          </a:prstGeom>
-          <a:noFill/>
-        </p:spPr>
-        <p:txBody>
-          <a:bodyPr wrap="square" lIns="0" rIns="0" tIns="0" bIns="0">
-            <a:spAutoFit/>
-          </a:bodyPr>
-          <a:lstStyle/>
-          <a:p>
-            <a:pPr algn="l"/>
-            <a:r>
-              <a:rPr sz="850" b="0" i="0">
+            <a:off x="365760" y="6601968"/>
+            <a:ext cx="7315200" cy="228600"/>
+          </a:xfrm>
+          <a:prstGeom prst="rect">
+            <a:avLst/>
+          </a:prstGeom>
+          <a:noFill/>
+        </p:spPr>
+        <p:txBody>
+          <a:bodyPr wrap="square" lIns="0" rIns="0" tIns="0" bIns="0">
+            <a:spAutoFit/>
+          </a:bodyPr>
+          <a:lstStyle/>
+          <a:p>
+            <a:pPr algn="l"/>
+            <a:r>
+              <a:rPr sz="800" b="0" i="0">
                 <a:solidFill>
                   <a:srgbClr val="707070"/>
                 </a:solidFill>
@@ -28027,8 +28027,8 @@
         </p:nvSpPr>
         <p:spPr>
           <a:xfrm>
-            <a:off x="10515600" y="6537960"/>
-            <a:ext cx="1371600" cy="274320"/>
+            <a:off x="10515600" y="6601968"/>
+            <a:ext cx="1371600" cy="228600"/>
           </a:xfrm>
           <a:prstGeom prst="rect">
             <a:avLst/>
@@ -28043,7 +28043,7 @@
           <a:p>
             <a:pPr algn="r"/>
             <a:r>
-              <a:rPr sz="850" b="0" i="0">
+              <a:rPr sz="800" b="0" i="0">
                 <a:solidFill>
                   <a:srgbClr val="707070"/>
                 </a:solidFill>
@@ -28803,23 +28803,23 @@
         </p:nvSpPr>
         <p:spPr>
           <a:xfrm>
-            <a:off x="365760" y="6537960"/>
-            <a:ext cx="7315200" cy="274320"/>
-          </a:xfrm>
-          <a:prstGeom prst="rect">
-            <a:avLst/>
-          </a:prstGeom>
-          <a:noFill/>
-        </p:spPr>
-        <p:txBody>
-          <a:bodyPr wrap="square" lIns="0" rIns="0" tIns="0" bIns="0">
-            <a:spAutoFit/>
-          </a:bodyPr>
-          <a:lstStyle/>
-          <a:p>
-            <a:pPr algn="l"/>
-            <a:r>
-              <a:rPr sz="850" b="0" i="0">
+            <a:off x="365760" y="6601968"/>
+            <a:ext cx="7315200" cy="228600"/>
+          </a:xfrm>
+          <a:prstGeom prst="rect">
+            <a:avLst/>
+          </a:prstGeom>
+          <a:noFill/>
+        </p:spPr>
+        <p:txBody>
+          <a:bodyPr wrap="square" lIns="0" rIns="0" tIns="0" bIns="0">
+            <a:spAutoFit/>
+          </a:bodyPr>
+          <a:lstStyle/>
+          <a:p>
+            <a:pPr algn="l"/>
+            <a:r>
+              <a:rPr sz="800" b="0" i="0">
                 <a:solidFill>
                   <a:srgbClr val="707070"/>
                 </a:solidFill>
@@ -28838,8 +28838,8 @@
         </p:nvSpPr>
         <p:spPr>
           <a:xfrm>
-            <a:off x="10515600" y="6537960"/>
-            <a:ext cx="1371600" cy="274320"/>
+            <a:off x="10515600" y="6601968"/>
+            <a:ext cx="1371600" cy="228600"/>
           </a:xfrm>
           <a:prstGeom prst="rect">
             <a:avLst/>
@@ -28854,7 +28854,7 @@
           <a:p>
             <a:pPr algn="r"/>
             <a:r>
-              <a:rPr sz="850" b="0" i="0">
+              <a:rPr sz="800" b="0" i="0">
                 <a:solidFill>
                   <a:srgbClr val="707070"/>
                 </a:solidFill>
@@ -29460,23 +29460,23 @@
         </p:nvSpPr>
         <p:spPr>
           <a:xfrm>
-            <a:off x="365760" y="6537960"/>
-            <a:ext cx="7315200" cy="274320"/>
-          </a:xfrm>
-          <a:prstGeom prst="rect">
-            <a:avLst/>
-          </a:prstGeom>
-          <a:noFill/>
-        </p:spPr>
-        <p:txBody>
-          <a:bodyPr wrap="square" lIns="0" rIns="0" tIns="0" bIns="0">
-            <a:spAutoFit/>
-          </a:bodyPr>
-          <a:lstStyle/>
-          <a:p>
-            <a:pPr algn="l"/>
-            <a:r>
-              <a:rPr sz="850" b="0" i="0">
+            <a:off x="365760" y="6601968"/>
+            <a:ext cx="7315200" cy="228600"/>
+          </a:xfrm>
+          <a:prstGeom prst="rect">
+            <a:avLst/>
+          </a:prstGeom>
+          <a:noFill/>
+        </p:spPr>
+        <p:txBody>
+          <a:bodyPr wrap="square" lIns="0" rIns="0" tIns="0" bIns="0">
+            <a:spAutoFit/>
+          </a:bodyPr>
+          <a:lstStyle/>
+          <a:p>
+            <a:pPr algn="l"/>
+            <a:r>
+              <a:rPr sz="800" b="0" i="0">
                 <a:solidFill>
                   <a:srgbClr val="707070"/>
                 </a:solidFill>
@@ -29495,8 +29495,8 @@
         </p:nvSpPr>
         <p:spPr>
           <a:xfrm>
-            <a:off x="10515600" y="6537960"/>
-            <a:ext cx="1371600" cy="274320"/>
+            <a:off x="10515600" y="6601968"/>
+            <a:ext cx="1371600" cy="228600"/>
           </a:xfrm>
           <a:prstGeom prst="rect">
             <a:avLst/>
@@ -29511,7 +29511,7 @@
           <a:p>
             <a:pPr algn="r"/>
             <a:r>
-              <a:rPr sz="850" b="0" i="0">
+              <a:rPr sz="800" b="0" i="0">
                 <a:solidFill>
                   <a:srgbClr val="707070"/>
                 </a:solidFill>
@@ -30060,23 +30060,23 @@
         </p:nvSpPr>
         <p:spPr>
           <a:xfrm>
-            <a:off x="365760" y="6537960"/>
-            <a:ext cx="7315200" cy="274320"/>
-          </a:xfrm>
-          <a:prstGeom prst="rect">
-            <a:avLst/>
-          </a:prstGeom>
-          <a:noFill/>
-        </p:spPr>
-        <p:txBody>
-          <a:bodyPr wrap="square" lIns="0" rIns="0" tIns="0" bIns="0">
-            <a:spAutoFit/>
-          </a:bodyPr>
-          <a:lstStyle/>
-          <a:p>
-            <a:pPr algn="l"/>
-            <a:r>
-              <a:rPr sz="850" b="0" i="0">
+            <a:off x="365760" y="6601968"/>
+            <a:ext cx="7315200" cy="228600"/>
+          </a:xfrm>
+          <a:prstGeom prst="rect">
+            <a:avLst/>
+          </a:prstGeom>
+          <a:noFill/>
+        </p:spPr>
+        <p:txBody>
+          <a:bodyPr wrap="square" lIns="0" rIns="0" tIns="0" bIns="0">
+            <a:spAutoFit/>
+          </a:bodyPr>
+          <a:lstStyle/>
+          <a:p>
+            <a:pPr algn="l"/>
+            <a:r>
+              <a:rPr sz="800" b="0" i="0">
                 <a:solidFill>
                   <a:srgbClr val="707070"/>
                 </a:solidFill>
@@ -30095,8 +30095,8 @@
         </p:nvSpPr>
         <p:spPr>
           <a:xfrm>
-            <a:off x="10515600" y="6537960"/>
-            <a:ext cx="1371600" cy="274320"/>
+            <a:off x="10515600" y="6601968"/>
+            <a:ext cx="1371600" cy="228600"/>
           </a:xfrm>
           <a:prstGeom prst="rect">
             <a:avLst/>
@@ -30111,7 +30111,7 @@
           <a:p>
             <a:pPr algn="r"/>
             <a:r>
-              <a:rPr sz="850" b="0" i="0">
+              <a:rPr sz="800" b="0" i="0">
                 <a:solidFill>
                   <a:srgbClr val="707070"/>
                 </a:solidFill>
@@ -32694,23 +32694,23 @@
         </p:nvSpPr>
         <p:spPr>
           <a:xfrm>
-            <a:off x="365760" y="6537960"/>
-            <a:ext cx="7315200" cy="274320"/>
-          </a:xfrm>
-          <a:prstGeom prst="rect">
-            <a:avLst/>
-          </a:prstGeom>
-          <a:noFill/>
-        </p:spPr>
-        <p:txBody>
-          <a:bodyPr wrap="square" lIns="0" rIns="0" tIns="0" bIns="0">
-            <a:spAutoFit/>
-          </a:bodyPr>
-          <a:lstStyle/>
-          <a:p>
-            <a:pPr algn="l"/>
-            <a:r>
-              <a:rPr sz="850" b="0" i="0">
+            <a:off x="365760" y="6601968"/>
+            <a:ext cx="7315200" cy="228600"/>
+          </a:xfrm>
+          <a:prstGeom prst="rect">
+            <a:avLst/>
+          </a:prstGeom>
+          <a:noFill/>
+        </p:spPr>
+        <p:txBody>
+          <a:bodyPr wrap="square" lIns="0" rIns="0" tIns="0" bIns="0">
+            <a:spAutoFit/>
+          </a:bodyPr>
+          <a:lstStyle/>
+          <a:p>
+            <a:pPr algn="l"/>
+            <a:r>
+              <a:rPr sz="800" b="0" i="0">
                 <a:solidFill>
                   <a:srgbClr val="707070"/>
                 </a:solidFill>
@@ -32729,8 +32729,8 @@
         </p:nvSpPr>
         <p:spPr>
           <a:xfrm>
-            <a:off x="10515600" y="6537960"/>
-            <a:ext cx="1371600" cy="274320"/>
+            <a:off x="10515600" y="6601968"/>
+            <a:ext cx="1371600" cy="228600"/>
           </a:xfrm>
           <a:prstGeom prst="rect">
             <a:avLst/>
@@ -32745,7 +32745,7 @@
           <a:p>
             <a:pPr algn="r"/>
             <a:r>
-              <a:rPr sz="850" b="0" i="0">
+              <a:rPr sz="800" b="0" i="0">
                 <a:solidFill>
                   <a:srgbClr val="707070"/>
                 </a:solidFill>
@@ -35428,23 +35428,23 @@
         </p:nvSpPr>
         <p:spPr>
           <a:xfrm>
-            <a:off x="365760" y="6537960"/>
-            <a:ext cx="7315200" cy="274320"/>
-          </a:xfrm>
-          <a:prstGeom prst="rect">
-            <a:avLst/>
-          </a:prstGeom>
-          <a:noFill/>
-        </p:spPr>
-        <p:txBody>
-          <a:bodyPr wrap="square" lIns="0" rIns="0" tIns="0" bIns="0">
-            <a:spAutoFit/>
-          </a:bodyPr>
-          <a:lstStyle/>
-          <a:p>
-            <a:pPr algn="l"/>
-            <a:r>
-              <a:rPr sz="850" b="0" i="0">
+            <a:off x="365760" y="6601968"/>
+            <a:ext cx="7315200" cy="228600"/>
+          </a:xfrm>
+          <a:prstGeom prst="rect">
+            <a:avLst/>
+          </a:prstGeom>
+          <a:noFill/>
+        </p:spPr>
+        <p:txBody>
+          <a:bodyPr wrap="square" lIns="0" rIns="0" tIns="0" bIns="0">
+            <a:spAutoFit/>
+          </a:bodyPr>
+          <a:lstStyle/>
+          <a:p>
+            <a:pPr algn="l"/>
+            <a:r>
+              <a:rPr sz="800" b="0" i="0">
                 <a:solidFill>
                   <a:srgbClr val="707070"/>
                 </a:solidFill>
@@ -35463,8 +35463,8 @@
         </p:nvSpPr>
         <p:spPr>
           <a:xfrm>
-            <a:off x="10515600" y="6537960"/>
-            <a:ext cx="1371600" cy="274320"/>
+            <a:off x="10515600" y="6601968"/>
+            <a:ext cx="1371600" cy="228600"/>
           </a:xfrm>
           <a:prstGeom prst="rect">
             <a:avLst/>
@@ -35479,7 +35479,7 @@
           <a:p>
             <a:pPr algn="r"/>
             <a:r>
-              <a:rPr sz="850" b="0" i="0">
+              <a:rPr sz="800" b="0" i="0">
                 <a:solidFill>
                   <a:srgbClr val="707070"/>
                 </a:solidFill>
@@ -36958,23 +36958,23 @@
         </p:nvSpPr>
         <p:spPr>
           <a:xfrm>
-            <a:off x="365760" y="6537960"/>
-            <a:ext cx="7315200" cy="274320"/>
-          </a:xfrm>
-          <a:prstGeom prst="rect">
-            <a:avLst/>
-          </a:prstGeom>
-          <a:noFill/>
-        </p:spPr>
-        <p:txBody>
-          <a:bodyPr wrap="square" lIns="0" rIns="0" tIns="0" bIns="0">
-            <a:spAutoFit/>
-          </a:bodyPr>
-          <a:lstStyle/>
-          <a:p>
-            <a:pPr algn="l"/>
-            <a:r>
-              <a:rPr sz="850" b="0" i="0">
+            <a:off x="365760" y="6601968"/>
+            <a:ext cx="7315200" cy="228600"/>
+          </a:xfrm>
+          <a:prstGeom prst="rect">
+            <a:avLst/>
+          </a:prstGeom>
+          <a:noFill/>
+        </p:spPr>
+        <p:txBody>
+          <a:bodyPr wrap="square" lIns="0" rIns="0" tIns="0" bIns="0">
+            <a:spAutoFit/>
+          </a:bodyPr>
+          <a:lstStyle/>
+          <a:p>
+            <a:pPr algn="l"/>
+            <a:r>
+              <a:rPr sz="800" b="0" i="0">
                 <a:solidFill>
                   <a:srgbClr val="707070"/>
                 </a:solidFill>
@@ -36993,8 +36993,8 @@
         </p:nvSpPr>
         <p:spPr>
           <a:xfrm>
-            <a:off x="10515600" y="6537960"/>
-            <a:ext cx="1371600" cy="274320"/>
+            <a:off x="10515600" y="6601968"/>
+            <a:ext cx="1371600" cy="228600"/>
           </a:xfrm>
           <a:prstGeom prst="rect">
             <a:avLst/>
@@ -37009,7 +37009,7 @@
           <a:p>
             <a:pPr algn="r"/>
             <a:r>
-              <a:rPr sz="850" b="0" i="0">
+              <a:rPr sz="800" b="0" i="0">
                 <a:solidFill>
                   <a:srgbClr val="707070"/>
                 </a:solidFill>
@@ -38381,23 +38381,23 @@
         </p:nvSpPr>
         <p:spPr>
           <a:xfrm>
-            <a:off x="365760" y="6537960"/>
-            <a:ext cx="7315200" cy="274320"/>
-          </a:xfrm>
-          <a:prstGeom prst="rect">
-            <a:avLst/>
-          </a:prstGeom>
-          <a:noFill/>
-        </p:spPr>
-        <p:txBody>
-          <a:bodyPr wrap="square" lIns="0" rIns="0" tIns="0" bIns="0">
-            <a:spAutoFit/>
-          </a:bodyPr>
-          <a:lstStyle/>
-          <a:p>
-            <a:pPr algn="l"/>
-            <a:r>
-              <a:rPr sz="850" b="0" i="0">
+            <a:off x="365760" y="6601968"/>
+            <a:ext cx="7315200" cy="228600"/>
+          </a:xfrm>
+          <a:prstGeom prst="rect">
+            <a:avLst/>
+          </a:prstGeom>
+          <a:noFill/>
+        </p:spPr>
+        <p:txBody>
+          <a:bodyPr wrap="square" lIns="0" rIns="0" tIns="0" bIns="0">
+            <a:spAutoFit/>
+          </a:bodyPr>
+          <a:lstStyle/>
+          <a:p>
+            <a:pPr algn="l"/>
+            <a:r>
+              <a:rPr sz="800" b="0" i="0">
                 <a:solidFill>
                   <a:srgbClr val="707070"/>
                 </a:solidFill>
@@ -38416,8 +38416,8 @@
         </p:nvSpPr>
         <p:spPr>
           <a:xfrm>
-            <a:off x="10515600" y="6537960"/>
-            <a:ext cx="1371600" cy="274320"/>
+            <a:off x="10515600" y="6601968"/>
+            <a:ext cx="1371600" cy="228600"/>
           </a:xfrm>
           <a:prstGeom prst="rect">
             <a:avLst/>
@@ -38432,7 +38432,7 @@
           <a:p>
             <a:pPr algn="r"/>
             <a:r>
-              <a:rPr sz="850" b="0" i="0">
+              <a:rPr sz="800" b="0" i="0">
                 <a:solidFill>
                   <a:srgbClr val="707070"/>
                 </a:solidFill>

</xml_diff>

<commit_message>
Slide 10: widen red + gray boxes (4.1→4.3in) to contain State column text
Co-Authored-By: Claude Opus 4.6 <noreply@anthropic.com>
</commit_message>
<xml_diff>
--- a/deck/Troy_K5_ELA_Executive_Summary.pptx
+++ b/deck/Troy_K5_ELA_Executive_Summary.pptx
@@ -3578,7 +3578,7 @@
         <p:spPr>
           <a:xfrm>
             <a:off x="8183879" y="914400"/>
-            <a:ext cx="3749039" cy="2880360"/>
+            <a:ext cx="3931920" cy="2880360"/>
           </a:xfrm>
           <a:prstGeom prst="rect">
             <a:avLst/>
@@ -4296,7 +4296,7 @@
         <p:spPr>
           <a:xfrm>
             <a:off x="8183879" y="3886200"/>
-            <a:ext cx="3749039" cy="2240280"/>
+            <a:ext cx="3931920" cy="2240280"/>
           </a:xfrm>
           <a:prstGeom prst="rect">
             <a:avLst/>

</xml_diff>